<commit_message>
Dashboard mit Veranstaltungs-Eckdaten + Outlook-Mailversand
- Dashboard-Blatt: Eckdaten (Art, Studienjahrgang, Datum, Uhrzeit,
  Einlass, Ort) als gelbe Eingabefelder plus komplette Anleitung;
  Werte ersetzen Platzhalter in der Slides-Vorlage bei der Generierung
- Design-Hintergrund von eingebackenen Veranstaltungstexten befreit
  (karte-vorderseite-neutral.png), Vorlage mit Platzhalter-Textfeldern
  an den Originalpositionen neu gebaut
- Einzel-PDFs pro Ticket (Vorder-+Rückseite) als ZIP-Download für den
  Mailversand, inkl. Versandliste.csv; PDF-Zerlegung per pdf-lib in
  25er-Segmenten
- Outlook-VBA-Makro SendTickets.bas: gruppiert PDFs pro Person, löst
  Empfänger über das Adressbuch auf, erstellt Entwürfe oder versendet

https://claude.ai/code/session_01PMA6QBiBZknqMxSCcwFkiS
</commit_message>
<xml_diff>
--- a/design/Eintrittskarten-Vorlage.pptx
+++ b/design/Eintrittskarten-Vorlage.pptx
@@ -3091,7 +3091,7 @@
       <p:grpSpPr/>
       <p:pic>
         <p:nvPicPr>
-          <p:cNvPr id="2" name="Picture 1" descr="bg-1.png"/>
+          <p:cNvPr id="2" name="Picture 1" descr="karte-vorderseite-neutral.png"/>
           <p:cNvPicPr>
             <a:picLocks noChangeAspect="1"/>
           </p:cNvPicPr>
@@ -3173,7 +3173,7 @@
         <p:spPr>
           <a:xfrm>
             <a:off x="50800" y="1422400"/>
-            <a:ext cx="1346200" cy="533400"/>
+            <a:ext cx="1346200" cy="381000"/>
           </a:xfrm>
           <a:prstGeom prst="rect">
             <a:avLst/>
@@ -3181,7 +3181,7 @@
           <a:noFill/>
         </p:spPr>
         <p:txBody>
-          <a:bodyPr wrap="square">
+          <a:bodyPr wrap="square" lIns="0" rIns="0" tIns="0" bIns="0">
             <a:spAutoFit/>
           </a:bodyPr>
           <a:lstStyle/>
@@ -3199,12 +3199,217 @@
           <a:p>
             <a:pPr algn="ctr"/>
             <a:r>
-              <a:rPr sz="800" b="0">
+              <a:rPr sz="800" b="1">
                 <a:solidFill>
                   <a:srgbClr val="FFFFFF"/>
                 </a:solidFill>
               </a:rPr>
               <a:t>{{TICKET}}</a:t>
+            </a:r>
+          </a:p>
+        </p:txBody>
+      </p:sp>
+      <p:sp>
+        <p:nvSpPr>
+          <p:cNvPr id="5" name="TextBox 4"/>
+          <p:cNvSpPr txBox="1"/>
+          <p:nvPr/>
+        </p:nvSpPr>
+        <p:spPr>
+          <a:xfrm>
+            <a:off x="25400" y="2197100"/>
+            <a:ext cx="1409700" cy="1295400"/>
+          </a:xfrm>
+          <a:prstGeom prst="rect">
+            <a:avLst/>
+          </a:prstGeom>
+          <a:noFill/>
+        </p:spPr>
+        <p:txBody>
+          <a:bodyPr wrap="square" lIns="0" rIns="0" tIns="0" bIns="0">
+            <a:spAutoFit/>
+          </a:bodyPr>
+          <a:lstStyle/>
+          <a:p>
+            <a:pPr algn="ctr"/>
+            <a:r>
+              <a:rPr sz="800" b="1">
+                <a:solidFill>
+                  <a:srgbClr val="FFFFFF"/>
+                </a:solidFill>
+              </a:rPr>
+              <a:t>{{ART_GROSS}}</a:t>
+            </a:r>
+          </a:p>
+          <a:p>
+            <a:pPr algn="ctr"/>
+            <a:r>
+              <a:rPr sz="800" b="1">
+                <a:solidFill>
+                  <a:srgbClr val="FFFFFF"/>
+                </a:solidFill>
+              </a:rPr>
+              <a:t>des Bachelor-</a:t>
+            </a:r>
+          </a:p>
+          <a:p>
+            <a:pPr algn="ctr"/>
+            <a:r>
+              <a:rPr sz="800" b="1">
+                <a:solidFill>
+                  <a:srgbClr val="FFFFFF"/>
+                </a:solidFill>
+              </a:rPr>
+              <a:t>Studienjahrgangs</a:t>
+            </a:r>
+          </a:p>
+          <a:p>
+            <a:pPr algn="ctr"/>
+            <a:r>
+              <a:rPr sz="800" b="1">
+                <a:solidFill>
+                  <a:srgbClr val="FFFFFF"/>
+                </a:solidFill>
+              </a:rPr>
+              <a:t>{{JAHRGANG}}</a:t>
+            </a:r>
+          </a:p>
+          <a:p>
+            <a:pPr algn="ctr"/>
+            <a:r>
+              <a:rPr sz="800" b="1">
+                <a:solidFill>
+                  <a:srgbClr val="FFFFFF"/>
+                </a:solidFill>
+              </a:rPr>
+              <a:t>{{DATUM}} um {{UHRZEIT}} Uhr</a:t>
+            </a:r>
+          </a:p>
+          <a:p>
+            <a:pPr algn="ctr"/>
+          </a:p>
+          <a:p>
+            <a:pPr algn="ctr"/>
+            <a:r>
+              <a:rPr sz="800" b="1">
+                <a:solidFill>
+                  <a:srgbClr val="FFFFFF"/>
+                </a:solidFill>
+              </a:rPr>
+              <a:t>Einlass ab {{EINLASS}} Uhr</a:t>
+            </a:r>
+          </a:p>
+        </p:txBody>
+      </p:sp>
+      <p:sp>
+        <p:nvSpPr>
+          <p:cNvPr id="6" name="TextBox 5"/>
+          <p:cNvSpPr txBox="1"/>
+          <p:nvPr/>
+        </p:nvSpPr>
+        <p:spPr>
+          <a:xfrm>
+            <a:off x="3848100" y="2374900"/>
+            <a:ext cx="3708400" cy="254000"/>
+          </a:xfrm>
+          <a:prstGeom prst="rect">
+            <a:avLst/>
+          </a:prstGeom>
+          <a:noFill/>
+        </p:spPr>
+        <p:txBody>
+          <a:bodyPr wrap="square" lIns="0" rIns="0" tIns="0" bIns="0">
+            <a:spAutoFit/>
+          </a:bodyPr>
+          <a:lstStyle/>
+          <a:p>
+            <a:pPr algn="l"/>
+            <a:r>
+              <a:rPr sz="1100" b="1">
+                <a:solidFill>
+                  <a:srgbClr val="384343"/>
+                </a:solidFill>
+              </a:rPr>
+              <a:t>{{DATUM_LANG}} | {{UHRZEIT}} Uhr</a:t>
+            </a:r>
+          </a:p>
+        </p:txBody>
+      </p:sp>
+      <p:sp>
+        <p:nvSpPr>
+          <p:cNvPr id="7" name="TextBox 6"/>
+          <p:cNvSpPr txBox="1"/>
+          <p:nvPr/>
+        </p:nvSpPr>
+        <p:spPr>
+          <a:xfrm>
+            <a:off x="3848100" y="2730500"/>
+            <a:ext cx="3733800" cy="558800"/>
+          </a:xfrm>
+          <a:prstGeom prst="rect">
+            <a:avLst/>
+          </a:prstGeom>
+          <a:noFill/>
+        </p:spPr>
+        <p:txBody>
+          <a:bodyPr wrap="square" lIns="0" rIns="0" tIns="0" bIns="0">
+            <a:spAutoFit/>
+          </a:bodyPr>
+          <a:lstStyle/>
+          <a:p>
+            <a:pPr algn="l"/>
+            <a:r>
+              <a:rPr sz="1200" b="1">
+                <a:solidFill>
+                  <a:srgbClr val="FFFFFF"/>
+                </a:solidFill>
+              </a:rPr>
+              <a:t>zur {{ART}} des</a:t>
+            </a:r>
+          </a:p>
+          <a:p>
+            <a:pPr algn="l"/>
+            <a:r>
+              <a:rPr sz="1200" b="1">
+                <a:solidFill>
+                  <a:srgbClr val="FFFFFF"/>
+                </a:solidFill>
+              </a:rPr>
+              <a:t>Bachelor-Studienjahrgangs {{JAHRGANG}}</a:t>
+            </a:r>
+          </a:p>
+        </p:txBody>
+      </p:sp>
+      <p:sp>
+        <p:nvSpPr>
+          <p:cNvPr id="8" name="TextBox 7"/>
+          <p:cNvSpPr txBox="1"/>
+          <p:nvPr/>
+        </p:nvSpPr>
+        <p:spPr>
+          <a:xfrm>
+            <a:off x="3848100" y="3314700"/>
+            <a:ext cx="3733800" cy="203200"/>
+          </a:xfrm>
+          <a:prstGeom prst="rect">
+            <a:avLst/>
+          </a:prstGeom>
+          <a:noFill/>
+        </p:spPr>
+        <p:txBody>
+          <a:bodyPr wrap="square" lIns="0" rIns="0" tIns="0" bIns="0">
+            <a:spAutoFit/>
+          </a:bodyPr>
+          <a:lstStyle/>
+          <a:p>
+            <a:pPr algn="l"/>
+            <a:r>
+              <a:rPr sz="700" b="1">
+                <a:solidFill>
+                  <a:srgbClr val="FFFFFF"/>
+                </a:solidFill>
+              </a:rPr>
+              <a:t>{{VERANSTALTUNGSORT}}</a:t>
             </a:r>
           </a:p>
         </p:txBody>

</xml_diff>